<commit_message>
refactoring - downsizing the tests. Focus on auth
</commit_message>
<xml_diff>
--- a/PRESENTATION.pptx
+++ b/PRESENTATION.pptx
@@ -142,7 +142,7 @@
                 </a:solidFill>
                 <a:latin typeface="Calibri"/>
               </a:rPr>
-              <a:t>Login-Stress: Latenz (ms) über Zeit</a:t>
+              <a:t>Login-Spike: Latenz (ms) über Zeit</a:t>
             </a:r>
           </a:p>
         </c:rich>
@@ -304,67 +304,67 @@
                 <c:formatCode>General</c:formatCode>
                 <c:ptCount val="21"/>
                 <c:pt idx="0">
-                  <c:v>71</c:v>
+                  <c:v>77</c:v>
                 </c:pt>
                 <c:pt idx="1">
-                  <c:v>64</c:v>
+                  <c:v>59</c:v>
                 </c:pt>
                 <c:pt idx="2">
-                  <c:v>50</c:v>
+                  <c:v>49</c:v>
                 </c:pt>
                 <c:pt idx="3">
                   <c:v>69</c:v>
                 </c:pt>
                 <c:pt idx="4">
-                  <c:v>92</c:v>
+                  <c:v>93</c:v>
                 </c:pt>
                 <c:pt idx="5">
-                  <c:v>181</c:v>
+                  <c:v>177</c:v>
                 </c:pt>
                 <c:pt idx="6">
-                  <c:v>540</c:v>
+                  <c:v>524</c:v>
                 </c:pt>
                 <c:pt idx="7">
-                  <c:v>896</c:v>
+                  <c:v>872</c:v>
                 </c:pt>
                 <c:pt idx="8">
-                  <c:v>1203</c:v>
+                  <c:v>1158</c:v>
                 </c:pt>
                 <c:pt idx="9">
-                  <c:v>1213</c:v>
+                  <c:v>1167</c:v>
                 </c:pt>
                 <c:pt idx="10">
-                  <c:v>1254</c:v>
+                  <c:v>1169</c:v>
                 </c:pt>
                 <c:pt idx="11">
-                  <c:v>1168</c:v>
+                  <c:v>1163</c:v>
                 </c:pt>
                 <c:pt idx="12">
-                  <c:v>1153</c:v>
+                  <c:v>1164</c:v>
                 </c:pt>
                 <c:pt idx="13">
+                  <c:v>1164</c:v>
+                </c:pt>
+                <c:pt idx="14">
+                  <c:v>1166</c:v>
+                </c:pt>
+                <c:pt idx="15">
+                  <c:v>1158</c:v>
+                </c:pt>
+                <c:pt idx="16">
+                  <c:v>1159</c:v>
+                </c:pt>
+                <c:pt idx="17">
+                  <c:v>1169</c:v>
+                </c:pt>
+                <c:pt idx="18">
                   <c:v>1154</c:v>
                 </c:pt>
-                <c:pt idx="14">
-                  <c:v>1171</c:v>
-                </c:pt>
-                <c:pt idx="15">
-                  <c:v>1166</c:v>
-                </c:pt>
-                <c:pt idx="16">
-                  <c:v>1167</c:v>
-                </c:pt>
-                <c:pt idx="17">
-                  <c:v>1172</c:v>
-                </c:pt>
-                <c:pt idx="18">
-                  <c:v>1165</c:v>
-                </c:pt>
                 <c:pt idx="19">
-                  <c:v>590</c:v>
+                  <c:v>582</c:v>
                 </c:pt>
                 <c:pt idx="20">
-                  <c:v>76</c:v>
+                  <c:v>57</c:v>
                 </c:pt>
               </c:numCache>
             </c:numRef>
@@ -520,67 +520,67 @@
                 <c:formatCode>General</c:formatCode>
                 <c:ptCount val="21"/>
                 <c:pt idx="0">
-                  <c:v>71</c:v>
+                  <c:v>77</c:v>
                 </c:pt>
                 <c:pt idx="1">
-                  <c:v>81</c:v>
+                  <c:v>77</c:v>
                 </c:pt>
                 <c:pt idx="2">
-                  <c:v>56</c:v>
+                  <c:v>51</c:v>
                 </c:pt>
                 <c:pt idx="3">
-                  <c:v>88</c:v>
+                  <c:v>79</c:v>
                 </c:pt>
                 <c:pt idx="4">
-                  <c:v>98</c:v>
+                  <c:v>99</c:v>
                 </c:pt>
                 <c:pt idx="5">
-                  <c:v>271</c:v>
+                  <c:v>261</c:v>
                 </c:pt>
                 <c:pt idx="6">
-                  <c:v>651</c:v>
+                  <c:v>612</c:v>
                 </c:pt>
                 <c:pt idx="7">
-                  <c:v>977</c:v>
+                  <c:v>935</c:v>
                 </c:pt>
                 <c:pt idx="8">
-                  <c:v>1233</c:v>
+                  <c:v>1163</c:v>
                 </c:pt>
                 <c:pt idx="9">
-                  <c:v>1230</c:v>
+                  <c:v>1170</c:v>
                 </c:pt>
                 <c:pt idx="10">
-                  <c:v>1285</c:v>
+                  <c:v>1174</c:v>
                 </c:pt>
                 <c:pt idx="11">
-                  <c:v>1210</c:v>
+                  <c:v>1168</c:v>
                 </c:pt>
                 <c:pt idx="12">
-                  <c:v>1159</c:v>
+                  <c:v>1171</c:v>
                 </c:pt>
                 <c:pt idx="13">
-                  <c:v>1165</c:v>
+                  <c:v>1170</c:v>
                 </c:pt>
                 <c:pt idx="14">
-                  <c:v>1180</c:v>
+                  <c:v>1173</c:v>
                 </c:pt>
                 <c:pt idx="15">
-                  <c:v>1179</c:v>
+                  <c:v>1164</c:v>
                 </c:pt>
                 <c:pt idx="16">
-                  <c:v>1179</c:v>
+                  <c:v>1164</c:v>
                 </c:pt>
                 <c:pt idx="17">
-                  <c:v>1187</c:v>
+                  <c:v>1176</c:v>
                 </c:pt>
                 <c:pt idx="18">
-                  <c:v>1180</c:v>
+                  <c:v>1168</c:v>
                 </c:pt>
                 <c:pt idx="19">
-                  <c:v>769</c:v>
+                  <c:v>752</c:v>
                 </c:pt>
                 <c:pt idx="20">
-                  <c:v>76</c:v>
+                  <c:v>57</c:v>
                 </c:pt>
               </c:numCache>
             </c:numRef>
@@ -1169,7 +1169,7 @@
           <a:p>
             <a:r>
               <a:rPr lang="en-US" dirty="0"/>
-              <a:t>Begrüßung. Wir haben für die geforkte conduit-App (RealWorld/Medium-Klon) ein komplettes Test-Setup über alle Stufen der Testpyramide aufgebaut, inklusive CI und Last-Tests. Schwerpunkt heute: was wurde warum und wie getestet.</a:t>
+              <a:t>Begrüßung. Wir haben für die conduit-App ein Test-Setup über alle Stufen der Testpyramide aufgebaut – mit bewusstem Schwerpunkt auf dem Authentifizierungs-/Login-Bereich, plus CI und Last-Tests.</a:t>
             </a:r>
             <a:endParaRPr lang="en-US" dirty="0"/>
           </a:p>
@@ -1257,7 +1257,7 @@
           <a:p>
             <a:r>
               <a:rPr lang="en-US" dirty="0"/>
-              <a:t>Zusammengefasst: 56 sinnvolle Tests über alle Stufen, Coverage von gut einem Prozent auf knapp 72 Prozent, realistische DB mit sauberer Isolation, eine automatisierte Pipeline und Last-Tests, die einen echten, erklärbaren Engpass aufdecken. Danke – Fragen?</a:t>
+              <a:t>Zusammengefasst: 26 fokussierte Tests über alle Stufen, Auth-Coverage von gut einem Prozent auf rund 85 Prozent, realistische DB mit sauberer Isolation, automatisierte Pipeline und Last-Tests, die einen echten Engpass aufdecken. Danke – Fragen?</a:t>
             </a:r>
             <a:endParaRPr lang="en-US" dirty="0"/>
           </a:p>
@@ -1345,7 +1345,7 @@
           <a:p>
             <a:r>
               <a:rPr lang="en-US" dirty="0"/>
-              <a:t>Kurzer Fahrplan: erst die App, dann unsere Teststrategie und die Pyramide, danach Werkzeuge und Isolation, die CI-Pipeline, die Last-Tests mit Ergebnissen und am Ende ein Fazit.</a:t>
+              <a:t>Kurzer Fahrplan: App und Fokus, Teststrategie und Pyramide, Werkzeuge und Isolation, CI-Pipeline, Last-Tests, Fazit.</a:t>
             </a:r>
             <a:endParaRPr lang="en-US" dirty="0"/>
           </a:p>
@@ -1433,7 +1433,7 @@
           <a:p>
             <a:r>
               <a:rPr lang="en-US" dirty="0"/>
-              <a:t>conduit ist die RealWorld-Referenz-App. Backend: Node/Express 5 mit Sequelize-ORM auf PostgreSQL, Auth über JWT und bcrypt. Frontend: React 19 mit Vite, spricht das Backend über /api an. Fachlich: Registrierung/Login, Artikel mit Kommentaren, Tags, Favoriten, Autoren folgen.</a:t>
+              <a:t>conduit: Express 5 + Sequelize + PostgreSQL, React-Frontend. Laut Aufgabenstellung müssen wir nur einen Teilbereich abdecken – wir haben den sicherheitskritischen Login-/Auth-Bereich gewählt und ihn über alle Pyramidenstufen getestet.</a:t>
             </a:r>
             <a:endParaRPr lang="en-US" dirty="0"/>
           </a:p>
@@ -1521,7 +1521,7 @@
           <a:p>
             <a:r>
               <a:rPr lang="en-US" dirty="0"/>
-              <a:t>Wichtig: Wir haben bewusst eine eigene Suite mit anderen Frameworks aufgebaut, statt die triviale Baseline zu erweitern – so ist der eigene Beitrag klar abgegrenzt. Und wir testen gegen echtes PostgreSQL, weil gerade Constraints wie Unique-E-Mail oder Slug auf SQLite falsch-positiv grün werden könnten. Ergebnis: Backend-Coverage von 1,3 auf knapp 72 Prozent.</a:t>
+              <a:t>Eigene Suite mit anderen Frameworks, klar abgegrenzt von der Baseline. Echtes Postgres wegen realistischer Constraints. Im Auth-Bereich haben wir die Coverage von gut 1 Prozent auf rund 85 Prozent gehoben.</a:t>
             </a:r>
             <a:endParaRPr lang="en-US" dirty="0"/>
           </a:p>
@@ -1609,7 +1609,7 @@
           <a:p>
             <a:r>
               <a:rPr lang="en-US" dirty="0"/>
-              <a:t>Die Pyramide hat die richtige Form: breite Unit-Basis, weniger Integration, wenige E2E, ganz oben Last. Zur Frage warum mehr als das Minimum: wir folgen dem Prinzip ein Test pro eigenständigem Code-Pfad. Bei den 30 Unit-Tests sind das z. B. Salting, die instanceof-Vererbung fürs Fehler-Mapping, jeder Status-Zweig. Bei Integration testen wir pro Endpunkt nicht nur den Erfolg, sondern auch die Fehlerpfade – genau die regressieren am häufigsten.</a:t>
+              <a:t>Die Pyramide hat die richtige Form: breite Unit-Basis, weniger Integration, wenige E2E, oben Last. Wir decken bewusst nur den Login-/Auth-Bereich ab, dafür durchgängig über alle Stufen – die Mindestmengen sind eingehalten.</a:t>
             </a:r>
             <a:endParaRPr lang="en-US" dirty="0"/>
           </a:p>
@@ -1697,7 +1697,7 @@
           <a:p>
             <a:r>
               <a:rPr lang="en-US" dirty="0"/>
-              <a:t>Womit getestet wird, sieht man hier – wichtiger ist das Wie der Isolation: Unit-Tests sind komplett gemockt. Integrationstests bekommen vor jedem Test eine leere Datenbank durch Truncate mit Cascade. E2E-Tests erzeugen je einen eindeutigen Benutzer, damit sie unabhängig und wiederholbar sind. Dadurch sind alle Stufen reproduzierbar.</a:t>
+              <a:t>Wichtig ist das Wie der Isolation: Unit komplett gemockt; Integration bekommt vor jedem Test eine leere DB via Truncate; E2E erzeugt je einen eindeutigen Benutzer. Dadurch sind alle Stufen unabhängig und reproduzierbar.</a:t>
             </a:r>
             <a:endParaRPr lang="en-US" dirty="0"/>
           </a:p>
@@ -1785,7 +1785,7 @@
           <a:p>
             <a:r>
               <a:rPr lang="en-US" dirty="0"/>
-              <a:t>Die Pipeline startet zuerst PostgreSQL per docker compose – das ist wichtig, weil Container-Services auf Windows-Runnern nicht laufen. Danach laufen alle Teststufen nacheinander. Die Last-Tests sind bewusst ausgelagert und nur manuell auslösbar. Die exakt gleichen npm-Skripte laufen auch lokal, daher voll reproduzierbar.</a:t>
+              <a:t>Die Pipeline startet zuerst PostgreSQL per docker compose (Container-Services laufen auf Windows-Runnern nicht), dann alle Teststufen nacheinander. Last-Tests sind ausgelagert und nur manuell auslösbar. Gleiche npm-Skripte laufen auch lokal.</a:t>
             </a:r>
             <a:endParaRPr lang="en-US" dirty="0"/>
           </a:p>
@@ -1873,7 +1873,7 @@
           <a:p>
             <a:r>
               <a:rPr lang="en-US" dirty="0"/>
-              <a:t>Zwei Szenarien: ein Lasttest auf den meistgenutzten Lese-Endpunkt und ein Stress-/Spike-Test auf den Login. Der Lesepfad bleibt mit p95 238 ms gesund. Beim Login sieht man im Diagramm deutlich: solange wenig Last anliegt, ist die Latenz unter 100 ms; sobald wir auf 100 gleichzeitige Nutzer springen, steigt sie auf rund 1,2 Sekunden. Keine Fehler, aber klare Verlangsamung.</a:t>
+              <a:t>Beide Last-Tests zielen auf den Login. Unter Normallast (15 VUs) bleibt p95 bei 188 ms. Beim Spike auf 100 VUs steigt die Latenz auf ein Plateau von rund 1,17 s – derselbe Endpunkt ist also etwa 6× langsamer. Keine Fehler, aber klare Verlangsamung.</a:t>
             </a:r>
             <a:endParaRPr lang="en-US" dirty="0"/>
           </a:p>
@@ -1961,7 +1961,7 @@
           <a:p>
             <a:r>
               <a:rPr lang="en-US" dirty="0"/>
-              <a:t>Die Interpretation: Der Lesepfad ist gesund, die Latenz kommt von Datenbankabfragen. Der Login dagegen ist CPU-gebunden – bcrypt ist mit Absicht rechenintensiv. Sobald die CPU sättigt, stauen sich die Anfragen, die Latenz steigt linear mit der Nebenläufigkeit, der Durchsatz deckelt. Das ist kein Bug, sondern eine Kapazitätsgrenze – lösbar über mehr Instanzen oder Rate-Limiting.</a:t>
+              <a:t>Gleicher Endpunkt, zwei Lastniveaus: Normallast ist unauffällig, der Spike deckt den CPU-gebundenen bcrypt-Engpass auf. Kein Bug, sondern eine Kapazitätsgrenze – lösbar über mehr Instanzen oder Rate-Limiting.</a:t>
             </a:r>
             <a:endParaRPr lang="en-US" dirty="0"/>
           </a:p>
@@ -2406,7 +2406,7 @@
                 <a:ea typeface="Calibri" pitchFamily="34" charset="-122"/>
                 <a:cs typeface="Calibri" pitchFamily="34" charset="-120"/>
               </a:rPr>
-              <a:t>Vollständiges Test-Setup &amp; Last-Analyse der conduit-App (RealWorld)</a:t>
+              <a:t>conduit (RealWorld) – Schwerpunkt Authentifizierung / Login</a:t>
             </a:r>
             <a:endParaRPr lang="en-US" sz="1800" dirty="0"/>
           </a:p>
@@ -2420,7 +2420,7 @@
         </p:nvSpPr>
         <p:spPr>
           <a:xfrm>
-            <a:off x="640080" y="3246120"/>
+            <a:off x="640080" y="3200400"/>
             <a:ext cx="7863840" cy="914400"/>
           </a:xfrm>
           <a:prstGeom prst="rect">
@@ -2590,7 +2590,7 @@
               <a:buNone/>
             </a:pPr>
             <a:r>
-              <a:rPr lang="en-US" sz="1600" dirty="0">
+              <a:rPr lang="en-US" sz="1500" dirty="0">
                 <a:solidFill>
                   <a:srgbClr val="FFFFFF"/>
                 </a:solidFill>
@@ -2598,9 +2598,9 @@
                 <a:ea typeface="Calibri" pitchFamily="34" charset="-122"/>
                 <a:cs typeface="Calibri" pitchFamily="34" charset="-120"/>
               </a:rPr>
-              <a:t>56 sinnvolle Tests über alle vier Pyramidenstufen (Ziel: 22)</a:t>
-            </a:r>
-            <a:endParaRPr lang="en-US" sz="1600" dirty="0"/>
+              <a:t>26 sinnvolle Tests, Fokus Login/Auth, über alle vier Pyramidenstufen (Ziel: 22)</a:t>
+            </a:r>
+            <a:endParaRPr lang="en-US" sz="1500" dirty="0"/>
           </a:p>
         </p:txBody>
       </p:sp>
@@ -2649,7 +2649,7 @@
               <a:buNone/>
             </a:pPr>
             <a:r>
-              <a:rPr lang="en-US" sz="1600" dirty="0">
+              <a:rPr lang="en-US" sz="1500" dirty="0">
                 <a:solidFill>
                   <a:srgbClr val="FFFFFF"/>
                 </a:solidFill>
@@ -2657,9 +2657,9 @@
                 <a:ea typeface="Calibri" pitchFamily="34" charset="-122"/>
                 <a:cs typeface="Calibri" pitchFamily="34" charset="-120"/>
               </a:rPr>
-              <a:t>Backend-Coverage von 1,3 % auf 71,7 % gehoben</a:t>
-            </a:r>
-            <a:endParaRPr lang="en-US" sz="1600" dirty="0"/>
+              <a:t>Auth-Coverage von 1,3 % auf 85,3 % gehoben</a:t>
+            </a:r>
+            <a:endParaRPr lang="en-US" sz="1500" dirty="0"/>
           </a:p>
         </p:txBody>
       </p:sp>
@@ -2708,7 +2708,7 @@
               <a:buNone/>
             </a:pPr>
             <a:r>
-              <a:rPr lang="en-US" sz="1600" dirty="0">
+              <a:rPr lang="en-US" sz="1500" dirty="0">
                 <a:solidFill>
                   <a:srgbClr val="FFFFFF"/>
                 </a:solidFill>
@@ -2718,7 +2718,7 @@
               </a:rPr>
               <a:t>Echte PostgreSQL-Test-DB + saubere Isolation pro Stufe</a:t>
             </a:r>
-            <a:endParaRPr lang="en-US" sz="1600" dirty="0"/>
+            <a:endParaRPr lang="en-US" sz="1500" dirty="0"/>
           </a:p>
         </p:txBody>
       </p:sp>
@@ -2767,7 +2767,7 @@
               <a:buNone/>
             </a:pPr>
             <a:r>
-              <a:rPr lang="en-US" sz="1600" dirty="0">
+              <a:rPr lang="en-US" sz="1500" dirty="0">
                 <a:solidFill>
                   <a:srgbClr val="FFFFFF"/>
                 </a:solidFill>
@@ -2777,7 +2777,7 @@
               </a:rPr>
               <a:t>Automatisierte CI-Pipeline, lokal reproduzierbar</a:t>
             </a:r>
-            <a:endParaRPr lang="en-US" sz="1600" dirty="0"/>
+            <a:endParaRPr lang="en-US" sz="1500" dirty="0"/>
           </a:p>
         </p:txBody>
       </p:sp>
@@ -2826,7 +2826,7 @@
               <a:buNone/>
             </a:pPr>
             <a:r>
-              <a:rPr lang="en-US" sz="1600" dirty="0">
+              <a:rPr lang="en-US" sz="1500" dirty="0">
                 <a:solidFill>
                   <a:srgbClr val="FFFFFF"/>
                 </a:solidFill>
@@ -2834,9 +2834,9 @@
                 <a:ea typeface="Calibri" pitchFamily="34" charset="-122"/>
                 <a:cs typeface="Calibri" pitchFamily="34" charset="-120"/>
               </a:rPr>
-              <a:t>Last-Tests decken realen Engpass auf (CPU-gebundener Login)</a:t>
-            </a:r>
-            <a:endParaRPr lang="en-US" sz="1600" dirty="0"/>
+              <a:t>Last-Tests decken realen Engpass auf (CPU-gebundener Login/bcrypt)</a:t>
+            </a:r>
+            <a:endParaRPr lang="en-US" sz="1500" dirty="0"/>
           </a:p>
         </p:txBody>
       </p:sp>
@@ -3042,7 +3042,7 @@
                 <a:ea typeface="Calibri" pitchFamily="34" charset="-122"/>
                 <a:cs typeface="Calibri" pitchFamily="34" charset="-120"/>
               </a:rPr>
-              <a:t>Die Anwendung</a:t>
+              <a:t>Die Anwendung &amp; Testfokus</a:t>
             </a:r>
             <a:endParaRPr lang="en-US" sz="1800" dirty="0"/>
           </a:p>
@@ -3603,7 +3603,7 @@
                 <a:ea typeface="Cambria" pitchFamily="34" charset="-122"/>
                 <a:cs typeface="Cambria" pitchFamily="34" charset="-120"/>
               </a:rPr>
-              <a:t>Die Anwendung: conduit (RealWorld)</a:t>
+              <a:t>Die Anwendung &amp; Testfokus</a:t>
             </a:r>
             <a:endParaRPr lang="en-US" sz="3000" dirty="0"/>
           </a:p>
@@ -3642,7 +3642,7 @@
                 <a:ea typeface="Calibri" pitchFamily="34" charset="-122"/>
                 <a:cs typeface="Calibri" pitchFamily="34" charset="-120"/>
               </a:rPr>
-              <a:t>Blogging-Plattform („Medium-Klon") nach der RealWorld-Spezifikation – Fullstack-Monorepo.</a:t>
+              <a:t>conduit – Blogging-Plattform („Medium-Klon") nach der RealWorld-Spezifikation, Fullstack-Monorepo.</a:t>
             </a:r>
             <a:endParaRPr lang="en-US" sz="1500" dirty="0"/>
           </a:p>
@@ -3656,7 +3656,7 @@
         </p:nvSpPr>
         <p:spPr>
           <a:xfrm>
-            <a:off x="548640" y="1828800"/>
+            <a:off x="548640" y="1783080"/>
             <a:ext cx="1737360" cy="914400"/>
           </a:xfrm>
           <a:prstGeom prst="roundRect">
@@ -3678,7 +3678,7 @@
         </p:nvSpPr>
         <p:spPr>
           <a:xfrm>
-            <a:off x="548640" y="1828800"/>
+            <a:off x="548640" y="1783080"/>
             <a:ext cx="1737360" cy="914400"/>
           </a:xfrm>
           <a:prstGeom prst="rect">
@@ -3734,7 +3734,7 @@
         </p:nvSpPr>
         <p:spPr>
           <a:xfrm>
-            <a:off x="2331720" y="2286000"/>
+            <a:off x="2331720" y="2240280"/>
             <a:ext cx="301752" cy="0"/>
           </a:xfrm>
           <a:prstGeom prst="line">
@@ -3758,7 +3758,7 @@
         </p:nvSpPr>
         <p:spPr>
           <a:xfrm>
-            <a:off x="2679192" y="1828800"/>
+            <a:off x="2679192" y="1783080"/>
             <a:ext cx="1737360" cy="914400"/>
           </a:xfrm>
           <a:prstGeom prst="roundRect">
@@ -3780,7 +3780,7 @@
         </p:nvSpPr>
         <p:spPr>
           <a:xfrm>
-            <a:off x="2679192" y="1828800"/>
+            <a:off x="2679192" y="1783080"/>
             <a:ext cx="1737360" cy="914400"/>
           </a:xfrm>
           <a:prstGeom prst="rect">
@@ -3836,7 +3836,7 @@
         </p:nvSpPr>
         <p:spPr>
           <a:xfrm>
-            <a:off x="4462272" y="2286000"/>
+            <a:off x="4462272" y="2240280"/>
             <a:ext cx="301752" cy="0"/>
           </a:xfrm>
           <a:prstGeom prst="line">
@@ -3860,7 +3860,7 @@
         </p:nvSpPr>
         <p:spPr>
           <a:xfrm>
-            <a:off x="4809744" y="1828800"/>
+            <a:off x="4809744" y="1783080"/>
             <a:ext cx="1737360" cy="914400"/>
           </a:xfrm>
           <a:prstGeom prst="roundRect">
@@ -3882,7 +3882,7 @@
         </p:nvSpPr>
         <p:spPr>
           <a:xfrm>
-            <a:off x="4809744" y="1828800"/>
+            <a:off x="4809744" y="1783080"/>
             <a:ext cx="1737360" cy="914400"/>
           </a:xfrm>
           <a:prstGeom prst="rect">
@@ -3938,7 +3938,7 @@
         </p:nvSpPr>
         <p:spPr>
           <a:xfrm>
-            <a:off x="6592824" y="2286000"/>
+            <a:off x="6592824" y="2240280"/>
             <a:ext cx="301752" cy="0"/>
           </a:xfrm>
           <a:prstGeom prst="line">
@@ -3962,7 +3962,7 @@
         </p:nvSpPr>
         <p:spPr>
           <a:xfrm>
-            <a:off x="6940296" y="1828800"/>
+            <a:off x="6940296" y="1783080"/>
             <a:ext cx="1737360" cy="914400"/>
           </a:xfrm>
           <a:prstGeom prst="roundRect">
@@ -3984,7 +3984,7 @@
         </p:nvSpPr>
         <p:spPr>
           <a:xfrm>
-            <a:off x="6940296" y="1828800"/>
+            <a:off x="6940296" y="1783080"/>
             <a:ext cx="1737360" cy="914400"/>
           </a:xfrm>
           <a:prstGeom prst="rect">
@@ -4023,7 +4023,7 @@
         </p:nvSpPr>
         <p:spPr>
           <a:xfrm>
-            <a:off x="548640" y="2852928"/>
+            <a:off x="548640" y="2788920"/>
             <a:ext cx="7955280" cy="274320"/>
           </a:xfrm>
           <a:prstGeom prst="rect">
@@ -4062,18 +4062,30 @@
         </p:nvSpPr>
         <p:spPr>
           <a:xfrm>
-            <a:off x="548640" y="4069080"/>
-            <a:ext cx="2560320" cy="548640"/>
+            <a:off x="548640" y="3886200"/>
+            <a:ext cx="8046720" cy="777240"/>
           </a:xfrm>
           <a:prstGeom prst="roundRect">
             <a:avLst>
-              <a:gd name="adj" fmla="val 13333"/>
+              <a:gd name="adj" fmla="val 9412"/>
             </a:avLst>
           </a:prstGeom>
           <a:solidFill>
             <a:srgbClr val="F1F5F9"/>
           </a:solidFill>
-          <a:ln/>
+          <a:ln w="12700">
+            <a:solidFill>
+              <a:srgbClr val="FFFFFF"/>
+            </a:solidFill>
+            <a:prstDash val="solid"/>
+          </a:ln>
+          <a:effectLst>
+            <a:outerShdw sx="100000" sy="100000" kx="0" ky="0" algn="bl" rotWithShape="0" blurRad="76200" dist="25400" dir="5400000">
+              <a:srgbClr val="94A3B8">
+                <a:alpha val="25000"/>
+              </a:srgbClr>
+            </a:outerShdw>
+          </a:effectLst>
         </p:spPr>
       </p:sp>
       <p:sp>
@@ -4084,8 +4096,8 @@
         </p:nvSpPr>
         <p:spPr>
           <a:xfrm>
-            <a:off x="548640" y="4069080"/>
-            <a:ext cx="2560320" cy="548640"/>
+            <a:off x="731520" y="3886200"/>
+            <a:ext cx="7680960" cy="777240"/>
           </a:xfrm>
           <a:prstGeom prst="rect">
             <a:avLst/>
@@ -4097,11 +4109,25 @@
           <a:bodyPr wrap="square" lIns="0" tIns="0" rIns="0" bIns="0" rtlCol="0" anchor="ctr"/>
           <a:lstStyle/>
           <a:p>
-            <a:pPr algn="ctr" indent="0" marL="0">
-              <a:buNone/>
-            </a:pPr>
-            <a:r>
-              <a:rPr lang="en-US" sz="1250" dirty="0">
+            <a:pPr indent="0" marL="0">
+              <a:buNone/>
+            </a:pPr>
+            <a:r>
+              <a:rPr lang="en-US" sz="1500" b="1" dirty="0">
+                <a:solidFill>
+                  <a:srgbClr val="028090"/>
+                </a:solidFill>
+                <a:latin typeface="Calibri" pitchFamily="34" charset="0"/>
+                <a:ea typeface="Calibri" pitchFamily="34" charset="-122"/>
+                <a:cs typeface="Calibri" pitchFamily="34" charset="-120"/>
+              </a:rPr>
+              <a:t>Testfokus dieser Arbeit:  </a:t>
+            </a:r>
+            <a:pPr indent="0" marL="0">
+              <a:buNone/>
+            </a:pPr>
+            <a:r>
+              <a:rPr lang="en-US" sz="1500" dirty="0">
                 <a:solidFill>
                   <a:srgbClr val="1E293B"/>
                 </a:solidFill>
@@ -4109,131 +4135,9 @@
                 <a:ea typeface="Calibri" pitchFamily="34" charset="-122"/>
                 <a:cs typeface="Calibri" pitchFamily="34" charset="-120"/>
               </a:rPr>
-              <a:t>Auth: Registrierung / Login</a:t>
-            </a:r>
-            <a:endParaRPr lang="en-US" sz="1250" dirty="0"/>
-          </a:p>
-        </p:txBody>
-      </p:sp>
-      <p:sp>
-        <p:nvSpPr>
-          <p:cNvPr id="18" name="Shape 16"/>
-          <p:cNvSpPr/>
-          <p:nvPr/>
-        </p:nvSpPr>
-        <p:spPr>
-          <a:xfrm>
-            <a:off x="3291840" y="4069080"/>
-            <a:ext cx="2560320" cy="548640"/>
-          </a:xfrm>
-          <a:prstGeom prst="roundRect">
-            <a:avLst>
-              <a:gd name="adj" fmla="val 13333"/>
-            </a:avLst>
-          </a:prstGeom>
-          <a:solidFill>
-            <a:srgbClr val="F1F5F9"/>
-          </a:solidFill>
-          <a:ln/>
-        </p:spPr>
-      </p:sp>
-      <p:sp>
-        <p:nvSpPr>
-          <p:cNvPr id="19" name="Text 17"/>
-          <p:cNvSpPr/>
-          <p:nvPr/>
-        </p:nvSpPr>
-        <p:spPr>
-          <a:xfrm>
-            <a:off x="3291840" y="4069080"/>
-            <a:ext cx="2560320" cy="548640"/>
-          </a:xfrm>
-          <a:prstGeom prst="rect">
-            <a:avLst/>
-          </a:prstGeom>
-          <a:noFill/>
-          <a:ln/>
-        </p:spPr>
-        <p:txBody>
-          <a:bodyPr wrap="square" lIns="0" tIns="0" rIns="0" bIns="0" rtlCol="0" anchor="ctr"/>
-          <a:lstStyle/>
-          <a:p>
-            <a:pPr algn="ctr" indent="0" marL="0">
-              <a:buNone/>
-            </a:pPr>
-            <a:r>
-              <a:rPr lang="en-US" sz="1250" dirty="0">
-                <a:solidFill>
-                  <a:srgbClr val="1E293B"/>
-                </a:solidFill>
-                <a:latin typeface="Calibri" pitchFamily="34" charset="0"/>
-                <a:ea typeface="Calibri" pitchFamily="34" charset="-122"/>
-                <a:cs typeface="Calibri" pitchFamily="34" charset="-120"/>
-              </a:rPr>
-              <a:t>Artikel-CRUD + Kommentare</a:t>
-            </a:r>
-            <a:endParaRPr lang="en-US" sz="1250" dirty="0"/>
-          </a:p>
-        </p:txBody>
-      </p:sp>
-      <p:sp>
-        <p:nvSpPr>
-          <p:cNvPr id="20" name="Shape 18"/>
-          <p:cNvSpPr/>
-          <p:nvPr/>
-        </p:nvSpPr>
-        <p:spPr>
-          <a:xfrm>
-            <a:off x="6035040" y="4069080"/>
-            <a:ext cx="2560320" cy="548640"/>
-          </a:xfrm>
-          <a:prstGeom prst="roundRect">
-            <a:avLst>
-              <a:gd name="adj" fmla="val 13333"/>
-            </a:avLst>
-          </a:prstGeom>
-          <a:solidFill>
-            <a:srgbClr val="F1F5F9"/>
-          </a:solidFill>
-          <a:ln/>
-        </p:spPr>
-      </p:sp>
-      <p:sp>
-        <p:nvSpPr>
-          <p:cNvPr id="21" name="Text 19"/>
-          <p:cNvSpPr/>
-          <p:nvPr/>
-        </p:nvSpPr>
-        <p:spPr>
-          <a:xfrm>
-            <a:off x="6035040" y="4069080"/>
-            <a:ext cx="2560320" cy="548640"/>
-          </a:xfrm>
-          <a:prstGeom prst="rect">
-            <a:avLst/>
-          </a:prstGeom>
-          <a:noFill/>
-          <a:ln/>
-        </p:spPr>
-        <p:txBody>
-          <a:bodyPr wrap="square" lIns="0" tIns="0" rIns="0" bIns="0" rtlCol="0" anchor="ctr"/>
-          <a:lstStyle/>
-          <a:p>
-            <a:pPr algn="ctr" indent="0" marL="0">
-              <a:buNone/>
-            </a:pPr>
-            <a:r>
-              <a:rPr lang="en-US" sz="1250" dirty="0">
-                <a:solidFill>
-                  <a:srgbClr val="1E293B"/>
-                </a:solidFill>
-                <a:latin typeface="Calibri" pitchFamily="34" charset="0"/>
-                <a:ea typeface="Calibri" pitchFamily="34" charset="-122"/>
-                <a:cs typeface="Calibri" pitchFamily="34" charset="-120"/>
-              </a:rPr>
-              <a:t>Tags · Favoriten · Follow</a:t>
-            </a:r>
-            <a:endParaRPr lang="en-US" sz="1250" dirty="0"/>
+              <a:t>Authentifizierung / Login (Registrierung, Login, Session) — nicht die gesamte App.</a:t>
+            </a:r>
+            <a:endParaRPr lang="en-US" sz="1500" dirty="0"/>
           </a:p>
         </p:txBody>
       </p:sp>
@@ -4444,7 +4348,7 @@
                 <a:ea typeface="Calibri" pitchFamily="34" charset="-122"/>
                 <a:cs typeface="Calibri" pitchFamily="34" charset="-120"/>
               </a:rPr>
-              <a:t>Eigene Suite mit Jest, Playwright und k6 –</a:t>
+              <a:t>Eigene Suite mit Jest, Playwright und k6;</a:t>
             </a:r>
             <a:endParaRPr lang="en-US" sz="1600" dirty="0"/>
           </a:p>
@@ -4464,7 +4368,7 @@
                 <a:ea typeface="Calibri" pitchFamily="34" charset="-122"/>
                 <a:cs typeface="Calibri" pitchFamily="34" charset="-120"/>
               </a:rPr>
-              <a:t>Vitest-Baseline bleibt als Vergleich erhalten.</a:t>
+              <a:t>Vitest-Baseline bleibt als Vergleich.</a:t>
             </a:r>
             <a:endParaRPr lang="en-US" sz="1600" dirty="0"/>
           </a:p>
@@ -4484,7 +4388,7 @@
                 <a:ea typeface="Calibri" pitchFamily="34" charset="-122"/>
                 <a:cs typeface="Calibri" pitchFamily="34" charset="-120"/>
               </a:rPr>
-              <a:t>Echtes PostgreSQL statt SQLite → realistische Szenarien.</a:t>
+              <a:t>Echtes PostgreSQL statt SQLite → realistisch.</a:t>
             </a:r>
             <a:endParaRPr lang="en-US" sz="1600" dirty="0"/>
           </a:p>
@@ -4557,7 +4461,7 @@
                 <a:ea typeface="Calibri" pitchFamily="34" charset="-122"/>
                 <a:cs typeface="Calibri" pitchFamily="34" charset="-120"/>
               </a:rPr>
-              <a:t>Code-Coverage (Backend)</a:t>
+              <a:t>Coverage (Auth-Bereich)</a:t>
             </a:r>
             <a:endParaRPr lang="en-US" sz="1200" dirty="0"/>
           </a:p>
@@ -4624,7 +4528,7 @@
                 <a:ea typeface="Calibri" pitchFamily="34" charset="-122"/>
                 <a:cs typeface="Calibri" pitchFamily="34" charset="-120"/>
               </a:rPr>
-              <a:t>71,7 %</a:t>
+              <a:t>85,3 %</a:t>
             </a:r>
             <a:endParaRPr lang="en-US" sz="2600" dirty="0"/>
           </a:p>
@@ -4697,7 +4601,7 @@
                 <a:ea typeface="Calibri" pitchFamily="34" charset="-122"/>
                 <a:cs typeface="Calibri" pitchFamily="34" charset="-120"/>
               </a:rPr>
-              <a:t>Vorher / Nachher</a:t>
+              <a:t>Auth-Module</a:t>
             </a:r>
             <a:endParaRPr lang="en-US" sz="1200" dirty="0"/>
           </a:p>
@@ -4711,8 +4615,8 @@
         </p:nvSpPr>
         <p:spPr>
           <a:xfrm>
-            <a:off x="5760720" y="3291840"/>
-            <a:ext cx="2743200" cy="1005840"/>
+            <a:off x="5760720" y="3246120"/>
+            <a:ext cx="2743200" cy="1051560"/>
           </a:xfrm>
           <a:prstGeom prst="rect">
             <a:avLst/>
@@ -4739,7 +4643,27 @@
                 <a:ea typeface="Calibri" pitchFamily="34" charset="-122"/>
                 <a:cs typeface="Calibri" pitchFamily="34" charset="-120"/>
               </a:rPr>
-              <a:t>Helper, Middleware, Models, Routes</a:t>
+              <a:t>bcrypt, jwt, authentication,</a:t>
+            </a:r>
+            <a:endParaRPr lang="en-US" sz="1300" dirty="0"/>
+          </a:p>
+          <a:p>
+            <a:pPr algn="ctr" indent="0" marL="0">
+              <a:lnSpc>
+                <a:spcPct val="120000"/>
+              </a:lnSpc>
+              <a:buNone/>
+            </a:pPr>
+            <a:r>
+              <a:rPr lang="en-US" sz="1300" dirty="0">
+                <a:solidFill>
+                  <a:srgbClr val="1E293B"/>
+                </a:solidFill>
+                <a:latin typeface="Calibri" pitchFamily="34" charset="0"/>
+                <a:ea typeface="Calibri" pitchFamily="34" charset="-122"/>
+                <a:cs typeface="Calibri" pitchFamily="34" charset="-120"/>
+              </a:rPr>
+              <a:t>User-Modell, Auth-Routen</a:t>
             </a:r>
             <a:endParaRPr lang="en-US" sz="1300" dirty="0"/>
           </a:p>
@@ -4830,7 +4754,7 @@
                 <a:ea typeface="Cambria" pitchFamily="34" charset="-122"/>
                 <a:cs typeface="Cambria" pitchFamily="34" charset="-120"/>
               </a:rPr>
-              <a:t>Testpyramide: 56 Tests gesamt</a:t>
+              <a:t>Testpyramide: 26 Tests (Auth-Fokus)</a:t>
             </a:r>
             <a:endParaRPr lang="en-US" sz="3000" dirty="0"/>
           </a:p>
@@ -4952,7 +4876,7 @@
                 <a:ea typeface="Calibri" pitchFamily="34" charset="-122"/>
                 <a:cs typeface="Calibri" pitchFamily="34" charset="-120"/>
               </a:rPr>
-              <a:t>E2E · 5</a:t>
+              <a:t>E2E · 4</a:t>
             </a:r>
             <a:endParaRPr lang="en-US" sz="1500" dirty="0"/>
           </a:p>
@@ -5013,7 +4937,7 @@
                 <a:ea typeface="Calibri" pitchFamily="34" charset="-122"/>
                 <a:cs typeface="Calibri" pitchFamily="34" charset="-120"/>
               </a:rPr>
-              <a:t>Integration · 19</a:t>
+              <a:t>Integration · 8</a:t>
             </a:r>
             <a:endParaRPr lang="en-US" sz="1500" dirty="0"/>
           </a:p>
@@ -5074,7 +4998,7 @@
                 <a:ea typeface="Calibri" pitchFamily="34" charset="-122"/>
                 <a:cs typeface="Calibri" pitchFamily="34" charset="-120"/>
               </a:rPr>
-              <a:t>Unit · 30</a:t>
+              <a:t>Unit · 12</a:t>
             </a:r>
             <a:endParaRPr lang="en-US" sz="1500" dirty="0"/>
           </a:p>
@@ -5116,7 +5040,7 @@
                 <a:ea typeface="Calibri" pitchFamily="34" charset="-122"/>
                 <a:cs typeface="Calibri" pitchFamily="34" charset="-120"/>
               </a:rPr>
-              <a:t>Warum so viele?</a:t>
+              <a:t>Fokus statt Breite</a:t>
             </a:r>
             <a:endParaRPr lang="en-US" sz="1600" dirty="0"/>
           </a:p>
@@ -5156,7 +5080,7 @@
                 <a:ea typeface="Calibri" pitchFamily="34" charset="-122"/>
                 <a:cs typeface="Calibri" pitchFamily="34" charset="-120"/>
               </a:rPr>
-              <a:t>Umgesetzt: 30 / 19 / 5 / 2 = 56</a:t>
+              <a:t>Umgesetzt: 12 / 8 / 4 / 2 = 26</a:t>
             </a:r>
             <a:endParaRPr lang="en-US" sz="1600" dirty="0"/>
           </a:p>
@@ -5196,7 +5120,7 @@
                 <a:ea typeface="Calibri" pitchFamily="34" charset="-122"/>
                 <a:cs typeface="Calibri" pitchFamily="34" charset="-120"/>
               </a:rPr>
-              <a:t>Prinzip: ein Test je eigenständigem Pfad / Edge-Case – kein Padding.</a:t>
+              <a:t>Nur der Login-/Auth-Bereich, dafür über alle Stufen.</a:t>
             </a:r>
             <a:endParaRPr lang="en-US" sz="1600" dirty="0"/>
           </a:p>
@@ -5216,7 +5140,7 @@
                 <a:ea typeface="Calibri" pitchFamily="34" charset="-122"/>
                 <a:cs typeface="Calibri" pitchFamily="34" charset="-120"/>
               </a:rPr>
-              <a:t>Integration: pro Endpunkt Happy Path UND Fehlerkontrakt (401/403/404/422).</a:t>
+              <a:t>Artikel, Kommentare, Tags bewusst ausgeklammert.</a:t>
             </a:r>
             <a:endParaRPr lang="en-US" sz="1600" dirty="0"/>
           </a:p>
@@ -5452,7 +5376,7 @@
               <a:buNone/>
             </a:pPr>
             <a:r>
-              <a:rPr lang="en-US" sz="1250" dirty="0">
+              <a:rPr lang="en-US" sz="1200" dirty="0">
                 <a:solidFill>
                   <a:srgbClr val="64748B"/>
                 </a:solidFill>
@@ -5460,9 +5384,9 @@
                 <a:ea typeface="Calibri" pitchFamily="34" charset="-122"/>
                 <a:cs typeface="Calibri" pitchFamily="34" charset="-120"/>
               </a:rPr>
-              <a:t>Reine Logik, Abhängigkeiten gemockt – voll deterministisch</a:t>
-            </a:r>
-            <a:endParaRPr lang="en-US" sz="1250" dirty="0"/>
+              <a:t>bcrypt / jwt / Auth-Middleware, Abhängigkeiten gemockt</a:t>
+            </a:r>
+            <a:endParaRPr lang="en-US" sz="1200" dirty="0"/>
           </a:p>
         </p:txBody>
       </p:sp>
@@ -5625,7 +5549,7 @@
               <a:buNone/>
             </a:pPr>
             <a:r>
-              <a:rPr lang="en-US" sz="1250" dirty="0">
+              <a:rPr lang="en-US" sz="1200" dirty="0">
                 <a:solidFill>
                   <a:srgbClr val="64748B"/>
                 </a:solidFill>
@@ -5633,9 +5557,9 @@
                 <a:ea typeface="Calibri" pitchFamily="34" charset="-122"/>
                 <a:cs typeface="Calibri" pitchFamily="34" charset="-120"/>
               </a:rPr>
-              <a:t>Echte API gegen PostgreSQL; Schema-Reset + Truncate pro Test</a:t>
-            </a:r>
-            <a:endParaRPr lang="en-US" sz="1250" dirty="0"/>
+              <a:t>Login-/Register-Endpunkte gegen echtes PostgreSQL; Truncate pro Test</a:t>
+            </a:r>
+            <a:endParaRPr lang="en-US" sz="1200" dirty="0"/>
           </a:p>
         </p:txBody>
       </p:sp>
@@ -5798,7 +5722,7 @@
               <a:buNone/>
             </a:pPr>
             <a:r>
-              <a:rPr lang="en-US" sz="1250" dirty="0">
+              <a:rPr lang="en-US" sz="1200" dirty="0">
                 <a:solidFill>
                   <a:srgbClr val="64748B"/>
                 </a:solidFill>
@@ -5806,9 +5730,9 @@
                 <a:ea typeface="Calibri" pitchFamily="34" charset="-122"/>
                 <a:cs typeface="Calibri" pitchFamily="34" charset="-120"/>
               </a:rPr>
-              <a:t>Browser-Flows; eigener, eindeutiger Benutzer pro Test</a:t>
-            </a:r>
-            <a:endParaRPr lang="en-US" sz="1250" dirty="0"/>
+              <a:t>Login-Flows im Browser; eigener, eindeutiger Benutzer pro Test</a:t>
+            </a:r>
+            <a:endParaRPr lang="en-US" sz="1200" dirty="0"/>
           </a:p>
         </p:txBody>
       </p:sp>
@@ -5971,7 +5895,7 @@
               <a:buNone/>
             </a:pPr>
             <a:r>
-              <a:rPr lang="en-US" sz="1250" dirty="0">
+              <a:rPr lang="en-US" sz="1200" dirty="0">
                 <a:solidFill>
                   <a:srgbClr val="64748B"/>
                 </a:solidFill>
@@ -5979,9 +5903,9 @@
                 <a:ea typeface="Calibri" pitchFamily="34" charset="-122"/>
                 <a:cs typeface="Calibri" pitchFamily="34" charset="-120"/>
               </a:rPr>
-              <a:t>Eigene Test-DB; Szenarien seeden ihre Daten selbst</a:t>
-            </a:r>
-            <a:endParaRPr lang="en-US" sz="1250" dirty="0"/>
+              <a:t>Login-Endpunkt unter Last; Szenarien seeden ihre Daten selbst</a:t>
+            </a:r>
+            <a:endParaRPr lang="en-US" sz="1200" dirty="0"/>
           </a:p>
         </p:txBody>
       </p:sp>
@@ -6656,7 +6580,7 @@
                 <a:ea typeface="Calibri" pitchFamily="34" charset="-122"/>
                 <a:cs typeface="Calibri" pitchFamily="34" charset="-120"/>
               </a:rPr>
-              <a:t>ausgelöster Workflow (ressourcenintensiv).</a:t>
+              <a:t>ausgelöster Workflow.</a:t>
             </a:r>
             <a:endParaRPr lang="en-US" sz="1400" dirty="0"/>
           </a:p>
@@ -6671,7 +6595,7 @@
         <p:spPr>
           <a:xfrm>
             <a:off x="457200" y="3840480"/>
-            <a:ext cx="8229600" cy="548640"/>
+            <a:ext cx="8229600" cy="365760"/>
           </a:xfrm>
           <a:prstGeom prst="rect">
             <a:avLst/>
@@ -6695,7 +6619,7 @@
                 <a:ea typeface="Calibri" pitchFamily="34" charset="-122"/>
                 <a:cs typeface="Calibri" pitchFamily="34" charset="-120"/>
               </a:rPr>
-              <a:t>Lokal identisch reproduzierbar  ·  docker compose statt services-Container (Windows-tauglich)  ·  Playwright-Report als Artifact</a:t>
+              <a:t>Lokal identisch reproduzierbar  ·  docker compose statt services-Container (Windows-tauglich)</a:t>
             </a:r>
             <a:endParaRPr lang="en-US" sz="1250" dirty="0"/>
           </a:p>
@@ -6766,7 +6690,7 @@
                 <a:ea typeface="Cambria" pitchFamily="34" charset="-122"/>
                 <a:cs typeface="Cambria" pitchFamily="34" charset="-120"/>
               </a:rPr>
-              <a:t>Last-Tests: zwei Szenarien</a:t>
+              <a:t>Last-Tests: Login normal vs. Spike</a:t>
             </a:r>
             <a:endParaRPr lang="en-US" sz="3000" dirty="0"/>
           </a:p>
@@ -6894,7 +6818,7 @@
                 <a:ea typeface="Calibri" pitchFamily="34" charset="-122"/>
                 <a:cs typeface="Calibri" pitchFamily="34" charset="-120"/>
               </a:rPr>
-              <a:t>GET /api/articles</a:t>
+              <a:t>Login – Normallast</a:t>
             </a:r>
             <a:endParaRPr lang="en-US" sz="1300" dirty="0"/>
           </a:p>
@@ -6933,7 +6857,7 @@
                 <a:ea typeface="Calibri" pitchFamily="34" charset="-122"/>
                 <a:cs typeface="Calibri" pitchFamily="34" charset="-120"/>
               </a:rPr>
-              <a:t>Lasttest</a:t>
+              <a:t>Lasttest · 15 VUs</a:t>
             </a:r>
             <a:endParaRPr lang="en-US" sz="1100" dirty="0"/>
           </a:p>
@@ -6975,7 +6899,7 @@
                 <a:ea typeface="Calibri" pitchFamily="34" charset="-122"/>
                 <a:cs typeface="Calibri" pitchFamily="34" charset="-120"/>
               </a:rPr>
-              <a:t>p95 238 ms</a:t>
+              <a:t>p95 188 ms</a:t>
             </a:r>
             <a:endParaRPr lang="en-US" sz="1900" dirty="0"/>
           </a:p>
@@ -6995,7 +6919,7 @@
                 <a:ea typeface="Calibri" pitchFamily="34" charset="-122"/>
                 <a:cs typeface="Calibri" pitchFamily="34" charset="-120"/>
               </a:rPr>
-              <a:t>0 % Fehler · 20 VUs</a:t>
+              <a:t>0 % Fehler · stabil</a:t>
             </a:r>
             <a:endParaRPr lang="en-US" sz="1900" dirty="0"/>
           </a:p>
@@ -7068,7 +6992,7 @@
                 <a:ea typeface="Calibri" pitchFamily="34" charset="-122"/>
                 <a:cs typeface="Calibri" pitchFamily="34" charset="-120"/>
               </a:rPr>
-              <a:t>POST /api/users/login</a:t>
+              <a:t>Login – Spike</a:t>
             </a:r>
             <a:endParaRPr lang="en-US" sz="1300" dirty="0"/>
           </a:p>
@@ -7107,7 +7031,7 @@
                 <a:ea typeface="Calibri" pitchFamily="34" charset="-122"/>
                 <a:cs typeface="Calibri" pitchFamily="34" charset="-120"/>
               </a:rPr>
-              <a:t>Stress / Spike</a:t>
+              <a:t>Stress · 100 VUs</a:t>
             </a:r>
             <a:endParaRPr lang="en-US" sz="1100" dirty="0"/>
           </a:p>
@@ -7149,7 +7073,7 @@
                 <a:ea typeface="Calibri" pitchFamily="34" charset="-122"/>
                 <a:cs typeface="Calibri" pitchFamily="34" charset="-120"/>
               </a:rPr>
-              <a:t>p95 1228 ms</a:t>
+              <a:t>p95 1171 ms</a:t>
             </a:r>
             <a:endParaRPr lang="en-US" sz="1900" dirty="0"/>
           </a:p>
@@ -7169,7 +7093,7 @@
                 <a:ea typeface="Calibri" pitchFamily="34" charset="-122"/>
                 <a:cs typeface="Calibri" pitchFamily="34" charset="-120"/>
               </a:rPr>
-              <a:t>0 % Fehler · 100 VUs</a:t>
+              <a:t>0 % Fehler · ≈ 6× langsamer</a:t>
             </a:r>
             <a:endParaRPr lang="en-US" sz="1900" dirty="0"/>
           </a:p>
@@ -7313,7 +7237,7 @@
                 <a:ea typeface="Calibri" pitchFamily="34" charset="-122"/>
                 <a:cs typeface="Calibri" pitchFamily="34" charset="-120"/>
               </a:rPr>
-              <a:t>Lesepfad – gesund</a:t>
+              <a:t>Normallast – gesund</a:t>
             </a:r>
             <a:endParaRPr lang="en-US" sz="1700" dirty="0"/>
           </a:p>
@@ -7356,7 +7280,7 @@
                 <a:ea typeface="Calibri" pitchFamily="34" charset="-122"/>
                 <a:cs typeface="Calibri" pitchFamily="34" charset="-120"/>
               </a:rPr>
-              <a:t>p95 238 ms bei 20 VUs, 0 % Fehler</a:t>
+              <a:t>15 VUs: p95 188 ms, 0 % Fehler</a:t>
             </a:r>
             <a:endParaRPr lang="en-US" sz="1350" dirty="0"/>
           </a:p>
@@ -7377,7 +7301,7 @@
                 <a:ea typeface="Calibri" pitchFamily="34" charset="-122"/>
                 <a:cs typeface="Calibri" pitchFamily="34" charset="-120"/>
               </a:rPr>
-              <a:t>Latenz von DB-Abfragen dominiert (N+1-Muster) – im Lastbereich unkritisch</a:t>
+              <a:t>Stabiles Plateau, Login unter erwarteter Last unauffällig</a:t>
             </a:r>
             <a:endParaRPr lang="en-US" sz="1350" dirty="0"/>
           </a:p>
@@ -7471,7 +7395,7 @@
                 <a:ea typeface="Calibri" pitchFamily="34" charset="-122"/>
                 <a:cs typeface="Calibri" pitchFamily="34" charset="-120"/>
               </a:rPr>
-              <a:t>Auth-Pfad – Engpass</a:t>
+              <a:t>Spike – Engpass</a:t>
             </a:r>
             <a:endParaRPr lang="en-US" sz="1700" dirty="0"/>
           </a:p>
@@ -7514,7 +7438,7 @@
                 <a:ea typeface="Calibri" pitchFamily="34" charset="-122"/>
                 <a:cs typeface="Calibri" pitchFamily="34" charset="-120"/>
               </a:rPr>
-              <a:t>≈ 70 ms → ≈ 1,2 s unter Spike (≈ 17× langsamer)</a:t>
+              <a:t>100 VUs: p95 ≈ 1,17 s (≈ 6× langsamer)</a:t>
             </a:r>
             <a:endParaRPr lang="en-US" sz="1350" dirty="0"/>
           </a:p>
@@ -7556,7 +7480,7 @@
                 <a:ea typeface="Calibri" pitchFamily="34" charset="-122"/>
                 <a:cs typeface="Calibri" pitchFamily="34" charset="-120"/>
               </a:rPr>
-              <a:t>Durchsatz deckelt bei ≈ 78 req/s – Kapazitätsgrenze, kein Fehler</a:t>
+              <a:t>Kapazitätsgrenze, kein Fehler (0 %)</a:t>
             </a:r>
             <a:endParaRPr lang="en-US" sz="1350" dirty="0"/>
           </a:p>

</xml_diff>